<commit_message>
docs: live dashboard link, presenter name and Hebrew video narration
- The dashboard is live on Streamlit Community Cloud at
  https://olist-late-delivery-1.streamlit.app. A headless browser check found all six
  pages rendering there, and Predict scoring an order.
- Slide 1 shows the presenter (Matanel), the code link and the live dashboard link.
  Slide 12 captions the screenshot with the live link. The deck and PDF are rebuilt.
- README dashboard row and docs/deploy.md link the live app.
- docs/video_narration_he.md holds the Hebrew narration for the nine segments, with the
  same timings and numbers as docs/video_script.md, which now links to it and points
  the dashboard take at the live app.

Co-Authored-By: Claude Opus 5.5 <noreply@anthropic.com>
</commit_message>
<xml_diff>
--- a/docs/presentation.pptx
+++ b/docs/presentation.pptx
@@ -4442,8 +4442,8 @@
         </p:nvSpPr>
         <p:spPr>
           <a:xfrm>
-            <a:off x="822960" y="4846320"/>
-            <a:ext cx="10515600" cy="914400"/>
+            <a:off x="822960" y="4069080"/>
+            <a:ext cx="10515600" cy="548640"/>
           </a:xfrm>
           <a:prstGeom prst="rect">
             <a:avLst/>
@@ -4458,6 +4458,40 @@
           <a:p>
             <a:pPr algn="l"/>
             <a:r>
+              <a:rPr sz="2200" b="1">
+                <a:solidFill>
+                  <a:srgbClr val="FFFFFF"/>
+                </a:solidFill>
+              </a:rPr>
+              <a:t>Matanel</a:t>
+            </a:r>
+          </a:p>
+        </p:txBody>
+      </p:sp>
+      <p:sp>
+        <p:nvSpPr>
+          <p:cNvPr id="7" name="TextBox 6"/>
+          <p:cNvSpPr txBox="1"/>
+          <p:nvPr/>
+        </p:nvSpPr>
+        <p:spPr>
+          <a:xfrm>
+            <a:off x="822960" y="4846320"/>
+            <a:ext cx="10515600" cy="1097280"/>
+          </a:xfrm>
+          <a:prstGeom prst="rect">
+            <a:avLst/>
+          </a:prstGeom>
+          <a:noFill/>
+        </p:spPr>
+        <p:txBody>
+          <a:bodyPr wrap="square">
+            <a:spAutoFit/>
+          </a:bodyPr>
+          <a:lstStyle/>
+          <a:p>
+            <a:pPr algn="l"/>
+            <a:r>
               <a:rPr sz="1600" b="0">
                 <a:solidFill>
                   <a:srgbClr val="CBD5E1"/>
@@ -4474,7 +4508,18 @@
                   <a:srgbClr val="CBD5E1"/>
                 </a:solidFill>
               </a:rPr>
-              <a:t>github.com/matnael332/olist-crewai-flow</a:t>
+              <a:t>Code: github.com/matnael332/olist-crewai-flow</a:t>
+            </a:r>
+          </a:p>
+          <a:p>
+            <a:pPr algn="l"/>
+            <a:r>
+              <a:rPr sz="1600" b="0">
+                <a:solidFill>
+                  <a:srgbClr val="CBD5E1"/>
+                </a:solidFill>
+              </a:rPr>
+              <a:t>Live dashboard: olist-late-delivery-1.streamlit.app</a:t>
             </a:r>
           </a:p>
         </p:txBody>
@@ -5734,7 +5779,7 @@
         <p:spPr>
           <a:xfrm>
             <a:off x="6263640" y="5029200"/>
-            <a:ext cx="5577840" cy="365760"/>
+            <a:ext cx="5577840" cy="640080"/>
           </a:xfrm>
           <a:prstGeom prst="rect">
             <a:avLst/>
@@ -5754,7 +5799,18 @@
                   <a:srgbClr val="64748B"/>
                 </a:solidFill>
               </a:rPr>
-              <a:t>Dashboard overview page, run final-llm-5</a:t>
+              <a:t>Live: olist-late-delivery-1.streamlit.app</a:t>
+            </a:r>
+          </a:p>
+          <a:p>
+            <a:pPr algn="l"/>
+            <a:r>
+              <a:rPr sz="1200" b="0">
+                <a:solidFill>
+                  <a:srgbClr val="64748B"/>
+                </a:solidFill>
+              </a:rPr>
+              <a:t>Overview page, run final-llm-5</a:t>
             </a:r>
           </a:p>
         </p:txBody>

</xml_diff>

<commit_message>
docs: live dashboard link, presenter name and Hebrew video narration (#12)
- The dashboard is live on Streamlit Community Cloud at
  https://olist-late-delivery-1.streamlit.app. A headless browser check found all six
  pages rendering there, and Predict scoring an order.
- Slide 1 shows the presenter (Matanel), the code link and the live dashboard link.
  Slide 12 captions the screenshot with the live link. The deck and PDF are rebuilt.
- README dashboard row and docs/deploy.md link the live app.
- docs/video_narration_he.md holds the Hebrew narration for the nine segments, with the
  same timings and numbers as docs/video_script.md, which now links to it and points
  the dashboard take at the live app.

Co-authored-by: Claude Opus 5.5 <noreply@anthropic.com>
</commit_message>
<xml_diff>
--- a/docs/presentation.pptx
+++ b/docs/presentation.pptx
@@ -4442,8 +4442,8 @@
         </p:nvSpPr>
         <p:spPr>
           <a:xfrm>
-            <a:off x="822960" y="4846320"/>
-            <a:ext cx="10515600" cy="914400"/>
+            <a:off x="822960" y="4069080"/>
+            <a:ext cx="10515600" cy="548640"/>
           </a:xfrm>
           <a:prstGeom prst="rect">
             <a:avLst/>
@@ -4458,6 +4458,40 @@
           <a:p>
             <a:pPr algn="l"/>
             <a:r>
+              <a:rPr sz="2200" b="1">
+                <a:solidFill>
+                  <a:srgbClr val="FFFFFF"/>
+                </a:solidFill>
+              </a:rPr>
+              <a:t>Matanel</a:t>
+            </a:r>
+          </a:p>
+        </p:txBody>
+      </p:sp>
+      <p:sp>
+        <p:nvSpPr>
+          <p:cNvPr id="7" name="TextBox 6"/>
+          <p:cNvSpPr txBox="1"/>
+          <p:nvPr/>
+        </p:nvSpPr>
+        <p:spPr>
+          <a:xfrm>
+            <a:off x="822960" y="4846320"/>
+            <a:ext cx="10515600" cy="1097280"/>
+          </a:xfrm>
+          <a:prstGeom prst="rect">
+            <a:avLst/>
+          </a:prstGeom>
+          <a:noFill/>
+        </p:spPr>
+        <p:txBody>
+          <a:bodyPr wrap="square">
+            <a:spAutoFit/>
+          </a:bodyPr>
+          <a:lstStyle/>
+          <a:p>
+            <a:pPr algn="l"/>
+            <a:r>
               <a:rPr sz="1600" b="0">
                 <a:solidFill>
                   <a:srgbClr val="CBD5E1"/>
@@ -4474,7 +4508,18 @@
                   <a:srgbClr val="CBD5E1"/>
                 </a:solidFill>
               </a:rPr>
-              <a:t>github.com/matnael332/olist-crewai-flow</a:t>
+              <a:t>Code: github.com/matnael332/olist-crewai-flow</a:t>
+            </a:r>
+          </a:p>
+          <a:p>
+            <a:pPr algn="l"/>
+            <a:r>
+              <a:rPr sz="1600" b="0">
+                <a:solidFill>
+                  <a:srgbClr val="CBD5E1"/>
+                </a:solidFill>
+              </a:rPr>
+              <a:t>Live dashboard: olist-late-delivery-1.streamlit.app</a:t>
             </a:r>
           </a:p>
         </p:txBody>
@@ -5734,7 +5779,7 @@
         <p:spPr>
           <a:xfrm>
             <a:off x="6263640" y="5029200"/>
-            <a:ext cx="5577840" cy="365760"/>
+            <a:ext cx="5577840" cy="640080"/>
           </a:xfrm>
           <a:prstGeom prst="rect">
             <a:avLst/>
@@ -5754,7 +5799,18 @@
                   <a:srgbClr val="64748B"/>
                 </a:solidFill>
               </a:rPr>
-              <a:t>Dashboard overview page, run final-llm-5</a:t>
+              <a:t>Live: olist-late-delivery-1.streamlit.app</a:t>
+            </a:r>
+          </a:p>
+          <a:p>
+            <a:pPr algn="l"/>
+            <a:r>
+              <a:rPr sz="1200" b="0">
+                <a:solidFill>
+                  <a:srgbClr val="64748B"/>
+                </a:solidFill>
+              </a:rPr>
+              <a:t>Overview page, run final-llm-5</a:t>
             </a:r>
           </a:p>
         </p:txBody>

</xml_diff>

<commit_message>
feat(frontend): Ops copilot chat page
The product layer for the agent operator, on top of the copilot core (#16)
and the risk policy (#15):

- Ops copilot page (new Operate section): passcode gate, 25 messages per
  session, quick replies answered from templates without an LLM, free text
  to Gemini with read-only tools, CSV attachment, and a result card with
  the real outcome of a replayed day plus ranked-list and action-list
  downloads.
- Risk scoring page uses the shared risk policy: recommended action per
  level and the customer-message draft for high risk.
- google-genai joins the frontend group; requirements.txt re-exported
  (still no crewai).
- Docs: README product section and screenshot, ADR-13 and ADR-14, the
  product layer in architecture.md, the secrets step in deploy.md, slides 4
  and 12, and a copilot segment in the video script and Hebrew narration.

Artifacts, model and gates are unchanged.

Co-Authored-By: Claude Opus 5.5 <noreply@anthropic.com>
</commit_message>
<xml_diff>
--- a/docs/presentation.pptx
+++ b/docs/presentation.pptx
@@ -723,7 +723,7 @@
           <a:lstStyle/>
           <a:p>
             <a:r>
-              <a:t>Run final-llm-6 produced the committed artifacts (llm mode).</a:t>
+              <a:t>Run final-llm-6 produced the committed artifacts (llm mode). Demo: replay 2018-07-16 in the copilot, download the action list, then ask a free question.</a:t>
             </a:r>
           </a:p>
         </p:txBody>
@@ -933,7 +933,7 @@
           <a:lstStyle/>
           <a:p>
             <a:r>
-              <a:t>Run-then-narrate: tested Python computes every artifact, agents inspect and explain; the Flow decides pass or fail. A failed gate stops the run and nothing is promoted.</a:t>
+              <a:t>Run-then-narrate: tested Python computes every artifact, agents inspect and explain; the Flow decides pass or fail. A failed gate stops the run and nothing is promoted. On top, three channels read the published artifacts through one risk policy.</a:t>
             </a:r>
           </a:p>
         </p:txBody>
@@ -5484,7 +5484,7 @@
                   <a:srgbClr val="2563EB"/>
                 </a:solidFill>
               </a:rPr>
-              <a:t>DEPLOYMENT AND NEXT STEPS</a:t>
+              <a:t>THE PRODUCT AND NEXT STEPS</a:t>
             </a:r>
           </a:p>
         </p:txBody>
@@ -5518,7 +5518,7 @@
                   <a:srgbClr val="0F172A"/>
                 </a:solidFill>
               </a:rPr>
-              <a:t>From notebook to product, and what comes next</a:t>
+              <a:t>From engine to product, and what comes next</a:t>
             </a:r>
           </a:p>
         </p:txBody>
@@ -5566,7 +5566,7 @@
         <p:spPr>
           <a:xfrm>
             <a:off x="548640" y="1463040"/>
-            <a:ext cx="5394960" cy="2651760"/>
+            <a:ext cx="5394960" cy="2743200"/>
           </a:xfrm>
           <a:prstGeom prst="rect">
             <a:avLst/>
@@ -5585,20 +5585,20 @@
               </a:spcAft>
             </a:pPr>
             <a:r>
-              <a:rPr b="1" sz="1500">
+              <a:rPr b="1" sz="1400">
                 <a:solidFill>
                   <a:srgbClr val="0F172A"/>
                 </a:solidFill>
               </a:rPr>
-              <a:t>Dashboard: </a:t>
-            </a:r>
-            <a:r>
-              <a:rPr sz="1500">
+              <a:t>Ops copilot: </a:t>
+            </a:r>
+            <a:r>
+              <a:rPr sz="1400">
                 <a:solidFill>
                   <a:srgbClr val="0F172A"/>
                 </a:solidFill>
               </a:rPr>
-              <a:t>Streamlit app over the committed artifacts: overview, insights, risk scoring, model, data contract, pipeline runs</a:t>
+              <a:t>a chat for the team that operates the agents: runs, gates, model and data; scores a CSV, a replayed day or one order. Read-only, every number sourced</a:t>
             </a:r>
           </a:p>
           <a:p>
@@ -5608,20 +5608,20 @@
               </a:spcAft>
             </a:pPr>
             <a:r>
-              <a:rPr b="1" sz="1500">
+              <a:rPr b="1" sz="1400">
                 <a:solidFill>
                   <a:srgbClr val="0F172A"/>
                 </a:solidFill>
               </a:rPr>
-              <a:t>API: </a:t>
-            </a:r>
-            <a:r>
-              <a:rPr sz="1500">
+              <a:t>Dashboard and API: </a:t>
+            </a:r>
+            <a:r>
+              <a:rPr sz="1400">
                 <a:solidFill>
                   <a:srgbClr val="0F172A"/>
                 </a:solidFill>
               </a:rPr>
-              <a:t>Flask /predict validates each order against the contract and returns the late probability and a top-10% risk flag</a:t>
+              <a:t>the same artifacts and one risk policy for people and systems</a:t>
             </a:r>
           </a:p>
           <a:p>
@@ -5631,7 +5631,7 @@
               </a:spcAft>
             </a:pPr>
             <a:r>
-              <a:rPr b="1" sz="1500">
+              <a:rPr b="1" sz="1400">
                 <a:solidFill>
                   <a:srgbClr val="0F172A"/>
                 </a:solidFill>
@@ -5639,7 +5639,7 @@
               <a:t>Run it: </a:t>
             </a:r>
             <a:r>
-              <a:rPr sz="1500">
+              <a:rPr sz="1400">
                 <a:solidFill>
                   <a:srgbClr val="0F172A"/>
                 </a:solidFill>
@@ -5657,8 +5657,8 @@
         </p:nvSpPr>
         <p:spPr>
           <a:xfrm>
-            <a:off x="548640" y="3291840"/>
-            <a:ext cx="5394960" cy="2011680"/>
+            <a:off x="548640" y="3429000"/>
+            <a:ext cx="5394960" cy="1828800"/>
           </a:xfrm>
           <a:prstGeom prst="rect">
             <a:avLst/>
@@ -5677,7 +5677,7 @@
               </a:spcAft>
             </a:pPr>
             <a:r>
-              <a:rPr b="1" sz="1500">
+              <a:rPr b="1" sz="1400">
                 <a:solidFill>
                   <a:srgbClr val="0F172A"/>
                 </a:solidFill>
@@ -5685,12 +5685,12 @@
               <a:t>Next: </a:t>
             </a:r>
             <a:r>
-              <a:rPr sz="1500">
+              <a:rPr sz="1400">
                 <a:solidFill>
                   <a:srgbClr val="0F172A"/>
                 </a:solidFill>
               </a:rPr>
-              <a:t>seller history features (past late rate, as of purchase time)</a:t>
+              <a:t>a Telegram bot and an 8:00 digest on the same copilot core</a:t>
             </a:r>
           </a:p>
           <a:p>
@@ -5700,7 +5700,7 @@
               </a:spcAft>
             </a:pPr>
             <a:r>
-              <a:rPr b="1" sz="1500">
+              <a:rPr b="1" sz="1400">
                 <a:solidFill>
                   <a:srgbClr val="0F172A"/>
                 </a:solidFill>
@@ -5708,12 +5708,12 @@
               <a:t>Next: </a:t>
             </a:r>
             <a:r>
-              <a:rPr sz="1500">
+              <a:rPr sz="1400">
                 <a:solidFill>
                   <a:srgbClr val="0F172A"/>
                 </a:solidFill>
               </a:rPr>
-              <a:t>delivery-days regression to set better promises</a:t>
+              <a:t>send the customer messages and track handled orders</a:t>
             </a:r>
           </a:p>
           <a:p>
@@ -5723,7 +5723,7 @@
               </a:spcAft>
             </a:pPr>
             <a:r>
-              <a:rPr b="1" sz="1500">
+              <a:rPr b="1" sz="1400">
                 <a:solidFill>
                   <a:srgbClr val="0F172A"/>
                 </a:solidFill>
@@ -5731,19 +5731,19 @@
               <a:t>Next: </a:t>
             </a:r>
             <a:r>
-              <a:rPr sz="1500">
+              <a:rPr sz="1400">
                 <a:solidFill>
                   <a:srgbClr val="0F172A"/>
                 </a:solidFill>
               </a:rPr>
-              <a:t>monthly retraining with drift and calibration monitoring by state</a:t>
+              <a:t>seller-history features and a delivery-days regression</a:t>
             </a:r>
           </a:p>
         </p:txBody>
       </p:sp>
       <p:pic>
         <p:nvPicPr>
-          <p:cNvPr id="8" name="Picture 7" descr="dashboard_overview.png"/>
+          <p:cNvPr id="8" name="Picture 7" descr="ops_copilot.png"/>
           <p:cNvPicPr>
             <a:picLocks noChangeAspect="1"/>
           </p:cNvPicPr>
@@ -5810,7 +5810,7 @@
                   <a:srgbClr val="64748B"/>
                 </a:solidFill>
               </a:rPr>
-              <a:t>Overview page, run final-llm-6</a:t>
+              <a:t>Ops copilot replaying 2018-07-16, with what really happened</a:t>
             </a:r>
           </a:p>
         </p:txBody>
@@ -7023,7 +7023,7 @@
                   <a:srgbClr val="0F172A"/>
                 </a:solidFill>
               </a:rPr>
-              <a:t>Two AI crews, one Flow, three quality gates</a:t>
+              <a:t>Two AI crews, three quality gates, one product</a:t>
             </a:r>
           </a:p>
         </p:txBody>
@@ -7915,14 +7915,308 @@
       </p:cxnSp>
       <p:sp>
         <p:nvSpPr>
-          <p:cNvPr id="23" name="TextBox 22"/>
+          <p:cNvPr id="23" name="Rounded Rectangle 22"/>
+          <p:cNvSpPr/>
+          <p:nvPr/>
+        </p:nvSpPr>
+        <p:spPr>
+          <a:xfrm>
+            <a:off x="4526280" y="4983480"/>
+            <a:ext cx="2148840" cy="777240"/>
+          </a:xfrm>
+          <a:prstGeom prst="roundRect">
+            <a:avLst/>
+          </a:prstGeom>
+          <a:solidFill>
+            <a:srgbClr val="DBEAFE"/>
+          </a:solidFill>
+          <a:ln>
+            <a:noFill/>
+          </a:ln>
+        </p:spPr>
+        <p:style>
+          <a:lnRef idx="1">
+            <a:schemeClr val="accent1"/>
+          </a:lnRef>
+          <a:fillRef idx="3">
+            <a:schemeClr val="accent1"/>
+          </a:fillRef>
+          <a:effectRef idx="2">
+            <a:schemeClr val="accent1"/>
+          </a:effectRef>
+          <a:fontRef idx="minor">
+            <a:schemeClr val="lt1"/>
+          </a:fontRef>
+        </p:style>
+        <p:txBody>
+          <a:bodyPr rtlCol="0" anchor="ctr" wrap="square"/>
+          <a:lstStyle/>
+          <a:p>
+            <a:pPr algn="ctr"/>
+            <a:r>
+              <a:rPr sz="1200" b="1">
+                <a:solidFill>
+                  <a:srgbClr val="0F172A"/>
+                </a:solidFill>
+              </a:rPr>
+              <a:t>Ops copilot</a:t>
+            </a:r>
+          </a:p>
+          <a:p>
+            <a:pPr algn="ctr"/>
+            <a:r>
+              <a:rPr sz="1000" b="0">
+                <a:solidFill>
+                  <a:srgbClr val="0F172A"/>
+                </a:solidFill>
+              </a:rPr>
+              <a:t>chat for the agent operator</a:t>
+            </a:r>
+          </a:p>
+        </p:txBody>
+      </p:sp>
+      <p:cxnSp>
+        <p:nvCxnSpPr>
+          <p:cNvPr id="24" name="Connector 23"/>
+          <p:cNvCxnSpPr/>
+          <p:nvPr/>
+        </p:nvCxnSpPr>
+        <p:spPr>
+          <a:xfrm flipH="1">
+            <a:off x="5596128" y="4434840"/>
+            <a:ext cx="2404872" cy="548640"/>
+          </a:xfrm>
+          <a:prstGeom prst="line">
+            <a:avLst/>
+          </a:prstGeom>
+          <a:ln w="25400">
+            <a:solidFill>
+              <a:srgbClr val="2563EB"/>
+            </a:solidFill>
+            <a:tailEnd type="triangle"/>
+          </a:ln>
+        </p:spPr>
+        <p:style>
+          <a:lnRef idx="2">
+            <a:schemeClr val="accent1"/>
+          </a:lnRef>
+          <a:fillRef idx="0">
+            <a:schemeClr val="accent1"/>
+          </a:fillRef>
+          <a:effectRef idx="1">
+            <a:schemeClr val="accent1"/>
+          </a:effectRef>
+          <a:fontRef idx="minor">
+            <a:schemeClr val="tx1"/>
+          </a:fontRef>
+        </p:style>
+      </p:cxnSp>
+      <p:sp>
+        <p:nvSpPr>
+          <p:cNvPr id="25" name="Rounded Rectangle 24"/>
+          <p:cNvSpPr/>
+          <p:nvPr/>
+        </p:nvSpPr>
+        <p:spPr>
+          <a:xfrm>
+            <a:off x="6812280" y="4983480"/>
+            <a:ext cx="2148840" cy="777240"/>
+          </a:xfrm>
+          <a:prstGeom prst="roundRect">
+            <a:avLst/>
+          </a:prstGeom>
+          <a:solidFill>
+            <a:srgbClr val="F1F5F9"/>
+          </a:solidFill>
+          <a:ln>
+            <a:noFill/>
+          </a:ln>
+        </p:spPr>
+        <p:style>
+          <a:lnRef idx="1">
+            <a:schemeClr val="accent1"/>
+          </a:lnRef>
+          <a:fillRef idx="3">
+            <a:schemeClr val="accent1"/>
+          </a:fillRef>
+          <a:effectRef idx="2">
+            <a:schemeClr val="accent1"/>
+          </a:effectRef>
+          <a:fontRef idx="minor">
+            <a:schemeClr val="lt1"/>
+          </a:fontRef>
+        </p:style>
+        <p:txBody>
+          <a:bodyPr rtlCol="0" anchor="ctr" wrap="square"/>
+          <a:lstStyle/>
+          <a:p>
+            <a:pPr algn="ctr"/>
+            <a:r>
+              <a:rPr sz="1200" b="1">
+                <a:solidFill>
+                  <a:srgbClr val="0F172A"/>
+                </a:solidFill>
+              </a:rPr>
+              <a:t>Dashboard</a:t>
+            </a:r>
+          </a:p>
+          <a:p>
+            <a:pPr algn="ctr"/>
+            <a:r>
+              <a:rPr sz="1000" b="0">
+                <a:solidFill>
+                  <a:srgbClr val="0F172A"/>
+                </a:solidFill>
+              </a:rPr>
+              <a:t>business + data science</a:t>
+            </a:r>
+          </a:p>
+        </p:txBody>
+      </p:sp>
+      <p:cxnSp>
+        <p:nvCxnSpPr>
+          <p:cNvPr id="26" name="Connector 25"/>
+          <p:cNvCxnSpPr/>
+          <p:nvPr/>
+        </p:nvCxnSpPr>
+        <p:spPr>
+          <a:xfrm flipH="1">
+            <a:off x="7882128" y="4434840"/>
+            <a:ext cx="118872" cy="548640"/>
+          </a:xfrm>
+          <a:prstGeom prst="line">
+            <a:avLst/>
+          </a:prstGeom>
+          <a:ln w="25400">
+            <a:solidFill>
+              <a:srgbClr val="2563EB"/>
+            </a:solidFill>
+            <a:tailEnd type="triangle"/>
+          </a:ln>
+        </p:spPr>
+        <p:style>
+          <a:lnRef idx="2">
+            <a:schemeClr val="accent1"/>
+          </a:lnRef>
+          <a:fillRef idx="0">
+            <a:schemeClr val="accent1"/>
+          </a:fillRef>
+          <a:effectRef idx="1">
+            <a:schemeClr val="accent1"/>
+          </a:effectRef>
+          <a:fontRef idx="minor">
+            <a:schemeClr val="tx1"/>
+          </a:fontRef>
+        </p:style>
+      </p:cxnSp>
+      <p:sp>
+        <p:nvSpPr>
+          <p:cNvPr id="27" name="Rounded Rectangle 26"/>
+          <p:cNvSpPr/>
+          <p:nvPr/>
+        </p:nvSpPr>
+        <p:spPr>
+          <a:xfrm>
+            <a:off x="9098280" y="4983480"/>
+            <a:ext cx="2148840" cy="777240"/>
+          </a:xfrm>
+          <a:prstGeom prst="roundRect">
+            <a:avLst/>
+          </a:prstGeom>
+          <a:solidFill>
+            <a:srgbClr val="F1F5F9"/>
+          </a:solidFill>
+          <a:ln>
+            <a:noFill/>
+          </a:ln>
+        </p:spPr>
+        <p:style>
+          <a:lnRef idx="1">
+            <a:schemeClr val="accent1"/>
+          </a:lnRef>
+          <a:fillRef idx="3">
+            <a:schemeClr val="accent1"/>
+          </a:fillRef>
+          <a:effectRef idx="2">
+            <a:schemeClr val="accent1"/>
+          </a:effectRef>
+          <a:fontRef idx="minor">
+            <a:schemeClr val="lt1"/>
+          </a:fontRef>
+        </p:style>
+        <p:txBody>
+          <a:bodyPr rtlCol="0" anchor="ctr" wrap="square"/>
+          <a:lstStyle/>
+          <a:p>
+            <a:pPr algn="ctr"/>
+            <a:r>
+              <a:rPr sz="1200" b="1">
+                <a:solidFill>
+                  <a:srgbClr val="0F172A"/>
+                </a:solidFill>
+              </a:rPr>
+              <a:t>API</a:t>
+            </a:r>
+          </a:p>
+          <a:p>
+            <a:pPr algn="ctr"/>
+            <a:r>
+              <a:rPr sz="1000" b="0">
+                <a:solidFill>
+                  <a:srgbClr val="0F172A"/>
+                </a:solidFill>
+              </a:rPr>
+              <a:t>/predict, /predict/batch, /risk-list</a:t>
+            </a:r>
+          </a:p>
+        </p:txBody>
+      </p:sp>
+      <p:cxnSp>
+        <p:nvCxnSpPr>
+          <p:cNvPr id="28" name="Connector 27"/>
+          <p:cNvCxnSpPr/>
+          <p:nvPr/>
+        </p:nvCxnSpPr>
+        <p:spPr>
+          <a:xfrm>
+            <a:off x="8001000" y="4434840"/>
+            <a:ext cx="2167128" cy="548640"/>
+          </a:xfrm>
+          <a:prstGeom prst="line">
+            <a:avLst/>
+          </a:prstGeom>
+          <a:ln w="25400">
+            <a:solidFill>
+              <a:srgbClr val="2563EB"/>
+            </a:solidFill>
+            <a:tailEnd type="triangle"/>
+          </a:ln>
+        </p:spPr>
+        <p:style>
+          <a:lnRef idx="2">
+            <a:schemeClr val="accent1"/>
+          </a:lnRef>
+          <a:fillRef idx="0">
+            <a:schemeClr val="accent1"/>
+          </a:fillRef>
+          <a:effectRef idx="1">
+            <a:schemeClr val="accent1"/>
+          </a:effectRef>
+          <a:fontRef idx="minor">
+            <a:schemeClr val="tx1"/>
+          </a:fontRef>
+        </p:style>
+      </p:cxnSp>
+      <p:sp>
+        <p:nvSpPr>
+          <p:cNvPr id="29" name="TextBox 28"/>
           <p:cNvSpPr txBox="1"/>
           <p:nvPr/>
         </p:nvSpPr>
         <p:spPr>
           <a:xfrm>
-            <a:off x="548640" y="4846320"/>
-            <a:ext cx="11155680" cy="1280160"/>
+            <a:off x="548640" y="4892040"/>
+            <a:ext cx="3840480" cy="1371600"/>
           </a:xfrm>
           <a:prstGeom prst="rect">
             <a:avLst/>
@@ -7937,23 +8231,23 @@
           <a:p>
             <a:pPr algn="l"/>
             <a:r>
-              <a:rPr sz="1500" b="0">
+              <a:rPr sz="1200" b="0">
                 <a:solidFill>
                   <a:srgbClr val="64748B"/>
                 </a:solidFill>
               </a:rPr>
-              <a:t>Crew 1: data engineer, documentation writer, analytics lead, insights writer, data steward, contract author.</a:t>
+              <a:t>Crew 1 (6 agents): data engineer, documentation writer, analytics lead, insights writer, data steward, contract author.</a:t>
             </a:r>
           </a:p>
           <a:p>
             <a:pPr algn="l"/>
             <a:r>
-              <a:rPr sz="1500" b="0">
+              <a:rPr sz="1200" b="0">
                 <a:solidFill>
                   <a:srgbClr val="64748B"/>
                 </a:solidFill>
               </a:rPr>
-              <a:t>Crew 2: feature engineer, feature reviewer, ML engineer, model reviewer, model card author. The contract version and hash travel with the handoff.</a:t>
+              <a:t>Crew 2 (5 agents): feature engineer and reviewer, ML engineer, model reviewer, model card author.</a:t>
             </a:r>
           </a:p>
         </p:txBody>

</xml_diff>